<commit_message>
Synchronize final project artifacts
</commit_message>
<xml_diff>
--- a/documents/GridCast_Europe_Referat.pptx
+++ b/documents/GridCast_Europe_Referat.pptx
@@ -2,22 +2,22 @@
 <file path=ppt/presentation.xml><?xml version="1.0" encoding="utf-8"?>
 <p:presentation xmlns:p="http://schemas.openxmlformats.org/presentationml/2006/main">
   <p:sldMasterIdLst>
-    <p:sldMasterId xmlns:r="http://schemas.openxmlformats.org/officeDocument/2006/relationships" id="2147483648" r:id="R870c03b9d6f141a4"/>
+    <p:sldMasterId xmlns:r="http://schemas.openxmlformats.org/officeDocument/2006/relationships" id="2147483648" r:id="Rde66a56b9b4b42e8"/>
   </p:sldMasterIdLst>
   <p:notesMasterIdLst>
-    <p:notesMasterId xmlns:r="http://schemas.openxmlformats.org/officeDocument/2006/relationships" r:id="Rb7a77f91d69d4101"/>
+    <p:notesMasterId xmlns:r="http://schemas.openxmlformats.org/officeDocument/2006/relationships" r:id="Rd65104047a0e40e0"/>
   </p:notesMasterIdLst>
   <p:sldIdLst>
-    <p:sldId xmlns:r="http://schemas.openxmlformats.org/officeDocument/2006/relationships" id="256" r:id="Rd2bfd5e402aa45fb"/>
-    <p:sldId xmlns:r="http://schemas.openxmlformats.org/officeDocument/2006/relationships" id="257" r:id="R68bf82e87a11499b"/>
-    <p:sldId xmlns:r="http://schemas.openxmlformats.org/officeDocument/2006/relationships" id="258" r:id="R709bbc6dd2384c76"/>
-    <p:sldId xmlns:r="http://schemas.openxmlformats.org/officeDocument/2006/relationships" id="259" r:id="Rc2d28b211b0d4ff0"/>
-    <p:sldId xmlns:r="http://schemas.openxmlformats.org/officeDocument/2006/relationships" id="260" r:id="Rc7b9cf03b2984bdd"/>
-    <p:sldId xmlns:r="http://schemas.openxmlformats.org/officeDocument/2006/relationships" id="261" r:id="Rf3736624a2874aad"/>
-    <p:sldId xmlns:r="http://schemas.openxmlformats.org/officeDocument/2006/relationships" id="262" r:id="R053c7a1bbbe14e8c"/>
-    <p:sldId xmlns:r="http://schemas.openxmlformats.org/officeDocument/2006/relationships" id="263" r:id="R68e082fe07d44bc2"/>
-    <p:sldId xmlns:r="http://schemas.openxmlformats.org/officeDocument/2006/relationships" id="264" r:id="R69cbb5c5e8ba4992"/>
-    <p:sldId xmlns:r="http://schemas.openxmlformats.org/officeDocument/2006/relationships" id="265" r:id="Rf48ad71517de47ad"/>
+    <p:sldId xmlns:r="http://schemas.openxmlformats.org/officeDocument/2006/relationships" id="256" r:id="Rb3d3176553324b5f"/>
+    <p:sldId xmlns:r="http://schemas.openxmlformats.org/officeDocument/2006/relationships" id="257" r:id="R3678a3f29a6443c3"/>
+    <p:sldId xmlns:r="http://schemas.openxmlformats.org/officeDocument/2006/relationships" id="258" r:id="Rb04782a5258846a3"/>
+    <p:sldId xmlns:r="http://schemas.openxmlformats.org/officeDocument/2006/relationships" id="259" r:id="R4e85fc94d0704a5a"/>
+    <p:sldId xmlns:r="http://schemas.openxmlformats.org/officeDocument/2006/relationships" id="260" r:id="Ra49612ecb685470f"/>
+    <p:sldId xmlns:r="http://schemas.openxmlformats.org/officeDocument/2006/relationships" id="261" r:id="Rcf7c42c42b144fdc"/>
+    <p:sldId xmlns:r="http://schemas.openxmlformats.org/officeDocument/2006/relationships" id="262" r:id="Rcabb253d83d3424b"/>
+    <p:sldId xmlns:r="http://schemas.openxmlformats.org/officeDocument/2006/relationships" id="263" r:id="R9188e74bfe894e8d"/>
+    <p:sldId xmlns:r="http://schemas.openxmlformats.org/officeDocument/2006/relationships" id="264" r:id="Rdb358a6fdcc84976"/>
+    <p:sldId xmlns:r="http://schemas.openxmlformats.org/officeDocument/2006/relationships" id="265" r:id="R9edcacde48ea4510"/>
   </p:sldIdLst>
   <p:sldSz cx="12192000" cy="6858000"/>
   <p:notesSz cx="6858000" cy="9144000"/>
@@ -941,6 +941,11 @@
           </a:p>
           <a:p xmlns:a="http://schemas.openxmlformats.org/drawingml/2006/main">
             <a:r>
+              <a:t>Technisch enthält die gemeinsame Datei alle Jahre. Für A³ wurde 2019 unmittelbar nach dem Einlesen ausgeschlossen und weder vorhergesagt, ausgewertet noch zum Tuning verwendet.</a:t>
+            </a:r>
+          </a:p>
+          <a:p xmlns:a="http://schemas.openxmlformats.org/drawingml/2006/main">
+            <a:r>
               <a:t>[Sources]</a:t>
             </a:r>
           </a:p>
@@ -1236,7 +1241,7 @@
           </a:p>
           <a:p xmlns:a="http://schemas.openxmlformats.org/drawingml/2006/main">
             <a:r>
-              <a:t>Die Übersicht nutzt eine interaktive Europakarte. Im Backtest sind Istwert, HGB und die gestrichelte Kalender-Baseline mit exakten Hoverwerten vergleichbar. Die Zukunftsansicht bietet fünf Presets und bleibt als transparente Was-wäre-wenn-Rechnung beschriftet.</a:t>
+              <a:t>Die Übersicht nutzt eine interaktive Europakarte. Im Backtest sind Istwert, HGB und die gestrichelte Kalender-Baseline mit exakten Hoverwerten vergleichbar. Die Zukunftsansicht bietet sieben Presets, direkte und diffuse Strahlungsregler sowie einen gekoppelten Zukunftspfad.</a:t>
             </a:r>
           </a:p>
           <a:p xmlns:a="http://schemas.openxmlformats.org/drawingml/2006/main">
@@ -1326,7 +1331,7 @@
           </a:p>
           <a:p xmlns:a="http://schemas.openxmlformats.org/drawingml/2006/main">
             <a:r>
-              <a:t>Für ein gewähltes Datum werden Kalenderfeatures und ein typisches Wetterprofil aus der Klimatologie 1980 bis 2019 erzeugt. Die Temperaturabweichung wirkt vor der ML-Inferenz.</a:t>
+              <a:t>Für ein gewähltes Datum werden Kalenderfeatures und ein typisches Wetterprofil aus der Klimatologie 1980 bis 2019 erzeugt. Temperaturabweichung sowie direkte und diffuse Sonneneinstrahlung verändern die Feature-Matrix vor einer erneuten ML-Inferenz.</a:t>
             </a:r>
           </a:p>
           <a:p xmlns:a="http://schemas.openxmlformats.org/drawingml/2006/main">
@@ -1341,7 +1346,12 @@
           </a:p>
           <a:p xmlns:a="http://schemas.openxmlformats.org/drawingml/2006/main">
             <a:r>
-              <a:t>Die fünf Presets sind illustrative Einstiegspunkte. Zusätzlich zeigt die App Tagesenergie, Spitzenzeit und Stunden oberhalb der historischen Quantilschwelle; alle Annahmen bleiben manuell veränderbar.</a:t>
+              <a:t>Die sieben Presets sind illustrative Einstiegspunkte. Zusätzlich koppelt ein Annahmenpfad von 2020 bis 2050 Temperatur, Nachfrage, Rechenzentrumslast sowie direkte und diffuse Strahlung; alle Einzelwerte bleiben manuell veränderbar.</a:t>
+            </a:r>
+          </a:p>
+          <a:p xmlns:a="http://schemas.openxmlformats.org/drawingml/2006/main">
+            <a:r>
+              <a:t>Nur die Nachfragegröße ist direkt an einen publizierten 2050-Szenariowert angelehnt. Temperatur, Rechenzentrumslast und die identische Strahlungsskalierung sind transparente Modellierungsannahmen auf Basis europäischer Quellenbefunde, keine länderscharfen Prognosen.</a:t>
             </a:r>
           </a:p>
           <a:p xmlns:a="http://schemas.openxmlformats.org/drawingml/2006/main">
@@ -1372,6 +1382,26 @@
           <a:p xmlns:a="http://schemas.openxmlformats.org/drawingml/2006/main">
             <a:r>
               <a:t>- reports/k_deployment.json</a:t>
+            </a:r>
+          </a:p>
+          <a:p xmlns:a="http://schemas.openxmlformats.org/drawingml/2006/main">
+            <a:r>
+              <a:t>- https://www.eea.europa.eu/en/analysis/indicators/global-and-european-temperatures</a:t>
+            </a:r>
+          </a:p>
+          <a:p xmlns:a="http://schemas.openxmlformats.org/drawingml/2006/main">
+            <a:r>
+              <a:t>- https://2024.entsos-tyndp-scenarios.eu/scenario-results/</a:t>
+            </a:r>
+          </a:p>
+          <a:p xmlns:a="http://schemas.openxmlformats.org/drawingml/2006/main">
+            <a:r>
+              <a:t>- https://www.iea.org/reports/energy-and-ai/energy-demand-from-ai</a:t>
+            </a:r>
+          </a:p>
+          <a:p xmlns:a="http://schemas.openxmlformats.org/drawingml/2006/main">
+            <a:r>
+              <a:t>- https://doi.org/10.1016/j.rse.2025.115122</a:t>
             </a:r>
           </a:p>
         </p:txBody>
@@ -1451,7 +1481,7 @@
           </a:p>
           <a:p xmlns:a="http://schemas.openxmlformats.org/drawingml/2006/main">
             <a:r>
-              <a:t>Elf Funktionstests bestehen. Zusätzlich laufen alle vier App-Ansichten und die Preset-Neuberechnung ohne Ausnahme.</a:t>
+              <a:t>34 von 34 Funktionstests bestehen. Zusätzlich laufen alle vier App-Ansichten und die Wetter-Preset-Neuberechnung ohne Ausnahme.</a:t>
             </a:r>
           </a:p>
           <a:p xmlns:a="http://schemas.openxmlformats.org/drawingml/2006/main">
@@ -1544,7 +1574,7 @@
   </p:cSld>
   <p:clrMap bg1="lt1" tx1="dk1" bg2="lt2" tx2="dk2" accent1="accent1" accent2="accent2" accent3="accent3" accent4="accent4" accent5="accent5" accent6="accent6" hlink="hlink" folHlink="folHlink"/>
   <p:sldLayoutIdLst>
-    <p:sldLayoutId xmlns:r="http://schemas.openxmlformats.org/officeDocument/2006/relationships" id="2147483649" r:id="Rb3c4dc64f26f4141"/>
+    <p:sldLayoutId xmlns:r="http://schemas.openxmlformats.org/officeDocument/2006/relationships" id="2147483649" r:id="R8d674bd2efd9400a"/>
   </p:sldLayoutIdLst>
   <p:txStyles>
     <p:titleStyle>
@@ -4656,7 +4686,7 @@
           <p:nvPr/>
         </p:nvPicPr>
         <p:blipFill>
-          <a:blip xmlns:r="http://schemas.openxmlformats.org/officeDocument/2006/relationships" xmlns:a="http://schemas.openxmlformats.org/drawingml/2006/main" r:embed="Reebd768739b64a7c"/>
+          <a:blip xmlns:r="http://schemas.openxmlformats.org/officeDocument/2006/relationships" xmlns:a="http://schemas.openxmlformats.org/drawingml/2006/main" r:embed="Rcda544f55c914b7d"/>
           <a:stretch xmlns:a="http://schemas.openxmlformats.org/drawingml/2006/main"/>
         </p:blipFill>
         <p:spPr>
@@ -4942,7 +4972,7 @@
           <p:nvPr/>
         </p:nvPicPr>
         <p:blipFill>
-          <a:blip xmlns:r="http://schemas.openxmlformats.org/officeDocument/2006/relationships" xmlns:a="http://schemas.openxmlformats.org/drawingml/2006/main" r:embed="R7beddc20fbe846f2"/>
+          <a:blip xmlns:r="http://schemas.openxmlformats.org/officeDocument/2006/relationships" xmlns:a="http://schemas.openxmlformats.org/drawingml/2006/main" r:embed="R12bc8654513b4e37"/>
           <a:stretch xmlns:a="http://schemas.openxmlformats.org/drawingml/2006/main"/>
         </p:blipFill>
         <p:spPr>
@@ -5349,7 +5379,7 @@
                   <a:srgbClr val="3164B2"/>
                 </a:solidFill>
               </a:rPr>
-              <a:t>2019 wurde weder geladen noch optimiert.</a:t>
+              <a:t>2019 nach Einlesen ausgeschlossen; keine Auswertung, kein Tuning.</a:t>
             </a:r>
           </a:p>
         </p:txBody>
@@ -5576,7 +5606,7 @@
           <p:nvPr/>
         </p:nvPicPr>
         <p:blipFill>
-          <a:blip xmlns:r="http://schemas.openxmlformats.org/officeDocument/2006/relationships" xmlns:a="http://schemas.openxmlformats.org/drawingml/2006/main" r:embed="R730317468afa46ed"/>
+          <a:blip xmlns:r="http://schemas.openxmlformats.org/officeDocument/2006/relationships" xmlns:a="http://schemas.openxmlformats.org/drawingml/2006/main" r:embed="R857967e2780f4bb8"/>
           <a:stretch xmlns:a="http://schemas.openxmlformats.org/drawingml/2006/main"/>
         </p:blipFill>
         <p:spPr>
@@ -6210,7 +6240,7 @@
           <p:nvPr/>
         </p:nvPicPr>
         <p:blipFill>
-          <a:blip xmlns:r="http://schemas.openxmlformats.org/officeDocument/2006/relationships" xmlns:a="http://schemas.openxmlformats.org/drawingml/2006/main" r:embed="Rd811255303e347ff"/>
+          <a:blip xmlns:r="http://schemas.openxmlformats.org/officeDocument/2006/relationships" xmlns:a="http://schemas.openxmlformats.org/drawingml/2006/main" r:embed="Re31f95767aa7491a"/>
           <a:stretch xmlns:a="http://schemas.openxmlformats.org/drawingml/2006/main"/>
         </p:blipFill>
         <p:spPr>
@@ -7677,7 +7707,7 @@
                   <a:srgbClr val="101318"/>
                 </a:solidFill>
               </a:rPr>
-              <a:t>Temperatur, Nachfrage und Rechenzentren</a:t>
+              <a:t>Wetter, Struktur und Zukunftspfad</a:t>
             </a:r>
           </a:p>
         </p:txBody>
@@ -8615,7 +8645,7 @@
                   <a:srgbClr val="5E6877"/>
                 </a:solidFill>
               </a:rPr>
-              <a:t>Median 1980-2019</a:t>
+              <a:t>Temperatur + direkte/diffuse Strahlung</a:t>
             </a:r>
           </a:p>
         </p:txBody>
@@ -9126,8 +9156,8 @@
         </p:nvSpPr>
         <p:spPr>
           <a:xfrm xmlns:a="http://schemas.openxmlformats.org/drawingml/2006/main">
-            <a:off x="1009650" y="3600450"/>
-            <a:ext cx="6191250" cy="381000"/>
+            <a:off x="1009650" y="3543300"/>
+            <a:ext cx="6191250" cy="742950"/>
           </a:xfrm>
           <a:prstGeom xmlns:a="http://schemas.openxmlformats.org/drawingml/2006/main" prst="rect">
             <a:avLst/>
@@ -9156,7 +9186,7 @@
                   <a:srgbClr val="102A4C"/>
                 </a:solidFill>
               </a:rPr>
-              <a:t>+2 °C  ·  +10 % Nachfrage  ·  +500 MW Rechenzentren</a:t>
+              <a:t>+2 °C · direkt 160 % · diffus 70 % · Nachfrage +10 % · Rechenzentren +500 MW</a:t>
             </a:r>
           </a:p>
         </p:txBody>
@@ -9870,7 +9900,7 @@
                   <a:srgbClr val="102A4C"/>
                 </a:solidFill>
               </a:rPr>
-              <a:t>11/11</a:t>
+              <a:t>34/34</a:t>
             </a:r>
           </a:p>
         </p:txBody>

</xml_diff>